<commit_message>
Slides e pdf terminati. In attesa del prof
</commit_message>
<xml_diff>
--- a/06_relazioni_e_parametri/Slides_v3/02_contesto.pptx
+++ b/06_relazioni_e_parametri/Slides_v3/02_contesto.pptx
@@ -8,7 +8,7 @@
     <p:notesMasterId r:id="rId3"/>
   </p:notesMasterIdLst>
   <p:sldIdLst>
-    <p:sldId id="256" r:id="rId2"/>
+    <p:sldId id="274" r:id="rId2"/>
   </p:sldIdLst>
   <p:sldSz cx="12192000" cy="6858000"/>
   <p:notesSz cx="6858000" cy="12192000"/>
@@ -635,15 +635,7 @@
 
 <file path=ppt/slides/slide1.xml><?xml version="1.0" encoding="utf-8"?>
 <p:sld xmlns:a="http://schemas.openxmlformats.org/drawingml/2006/main" xmlns:r="http://schemas.openxmlformats.org/officeDocument/2006/relationships" xmlns:p="http://schemas.openxmlformats.org/presentationml/2006/main">
-  <p:cSld name="Slide 1">
-    <p:bg>
-      <p:bgPr>
-        <a:solidFill>
-          <a:srgbClr val="FFFFFF"/>
-        </a:solidFill>
-        <a:effectLst/>
-      </p:bgPr>
-    </p:bg>
+  <p:cSld>
     <p:spTree>
       <p:nvGrpSpPr>
         <p:cNvPr id="1" name=""/>
@@ -722,7 +714,7 @@
               <a:buNone/>
             </a:pPr>
             <a:r>
-              <a:rPr lang="en-US" sz="3800" b="1" dirty="0">
+              <a:rPr lang="en-US" sz="3600" b="1" dirty="0">
                 <a:solidFill>
                   <a:srgbClr val="16233A"/>
                 </a:solidFill>
@@ -732,7 +724,7 @@
               </a:rPr>
               <a:t>Contesto</a:t>
             </a:r>
-            <a:endParaRPr lang="en-US" sz="3800" dirty="0"/>
+            <a:endParaRPr lang="en-US" sz="3600" dirty="0"/>
           </a:p>
         </p:txBody>
       </p:sp>
@@ -2335,1007 +2327,6 @@
   <p:transition spd="med">
     <p:fade/>
   </p:transition>
-  <p:timing>
-    <p:tnLst>
-      <p:par>
-        <p:cTn id="1" dur="indefinite" restart="never" nodeType="tmRoot">
-          <p:childTnLst>
-            <p:seq concurrent="1" nextAc="seek">
-              <p:cTn id="2" dur="indefinite" nodeType="mainSeq">
-                <p:childTnLst>
-                  <p:par>
-                    <p:cTn id="3" fill="hold">
-                      <p:stCondLst>
-                        <p:cond delay="indefinite"/>
-                      </p:stCondLst>
-                      <p:childTnLst>
-                        <p:par>
-                          <p:cTn id="4" fill="hold">
-                            <p:stCondLst>
-                              <p:cond delay="0"/>
-                            </p:stCondLst>
-                            <p:childTnLst>
-                              <p:par>
-                                <p:cTn id="5" presetID="42" presetClass="entr" presetSubtype="0" fill="hold" nodeType="clickEffect">
-                                  <p:stCondLst>
-                                    <p:cond delay="0"/>
-                                  </p:stCondLst>
-                                  <p:childTnLst>
-                                    <p:set>
-                                      <p:cBhvr>
-                                        <p:cTn id="6" dur="1" fill="hold">
-                                          <p:stCondLst>
-                                            <p:cond delay="0"/>
-                                          </p:stCondLst>
-                                        </p:cTn>
-                                        <p:tgtEl>
-                                          <p:spTgt spid="15"/>
-                                        </p:tgtEl>
-                                        <p:attrNameLst>
-                                          <p:attrName>style.visibility</p:attrName>
-                                        </p:attrNameLst>
-                                      </p:cBhvr>
-                                      <p:to>
-                                        <p:strVal val="visible"/>
-                                      </p:to>
-                                    </p:set>
-                                    <p:animEffect transition="in" filter="fade">
-                                      <p:cBhvr>
-                                        <p:cTn id="7" dur="1000"/>
-                                        <p:tgtEl>
-                                          <p:spTgt spid="15"/>
-                                        </p:tgtEl>
-                                      </p:cBhvr>
-                                    </p:animEffect>
-                                    <p:anim calcmode="lin" valueType="num">
-                                      <p:cBhvr>
-                                        <p:cTn id="8" dur="1000" fill="hold"/>
-                                        <p:tgtEl>
-                                          <p:spTgt spid="15"/>
-                                        </p:tgtEl>
-                                        <p:attrNameLst>
-                                          <p:attrName>ppt_x</p:attrName>
-                                        </p:attrNameLst>
-                                      </p:cBhvr>
-                                      <p:tavLst>
-                                        <p:tav tm="0">
-                                          <p:val>
-                                            <p:strVal val="#ppt_x"/>
-                                          </p:val>
-                                        </p:tav>
-                                        <p:tav tm="100000">
-                                          <p:val>
-                                            <p:strVal val="#ppt_x"/>
-                                          </p:val>
-                                        </p:tav>
-                                      </p:tavLst>
-                                    </p:anim>
-                                    <p:anim calcmode="lin" valueType="num">
-                                      <p:cBhvr>
-                                        <p:cTn id="9" dur="1000" fill="hold"/>
-                                        <p:tgtEl>
-                                          <p:spTgt spid="15"/>
-                                        </p:tgtEl>
-                                        <p:attrNameLst>
-                                          <p:attrName>ppt_y</p:attrName>
-                                        </p:attrNameLst>
-                                      </p:cBhvr>
-                                      <p:tavLst>
-                                        <p:tav tm="0">
-                                          <p:val>
-                                            <p:strVal val="#ppt_y+.1"/>
-                                          </p:val>
-                                        </p:tav>
-                                        <p:tav tm="100000">
-                                          <p:val>
-                                            <p:strVal val="#ppt_y"/>
-                                          </p:val>
-                                        </p:tav>
-                                      </p:tavLst>
-                                    </p:anim>
-                                  </p:childTnLst>
-                                </p:cTn>
-                              </p:par>
-                              <p:par>
-                                <p:cTn id="10" presetID="42" presetClass="entr" presetSubtype="0" fill="hold" grpId="0" nodeType="withEffect">
-                                  <p:stCondLst>
-                                    <p:cond delay="0"/>
-                                  </p:stCondLst>
-                                  <p:childTnLst>
-                                    <p:set>
-                                      <p:cBhvr>
-                                        <p:cTn id="11" dur="1" fill="hold">
-                                          <p:stCondLst>
-                                            <p:cond delay="0"/>
-                                          </p:stCondLst>
-                                        </p:cTn>
-                                        <p:tgtEl>
-                                          <p:spTgt spid="5"/>
-                                        </p:tgtEl>
-                                        <p:attrNameLst>
-                                          <p:attrName>style.visibility</p:attrName>
-                                        </p:attrNameLst>
-                                      </p:cBhvr>
-                                      <p:to>
-                                        <p:strVal val="visible"/>
-                                      </p:to>
-                                    </p:set>
-                                    <p:animEffect transition="in" filter="fade">
-                                      <p:cBhvr>
-                                        <p:cTn id="12" dur="1000"/>
-                                        <p:tgtEl>
-                                          <p:spTgt spid="5"/>
-                                        </p:tgtEl>
-                                      </p:cBhvr>
-                                    </p:animEffect>
-                                    <p:anim calcmode="lin" valueType="num">
-                                      <p:cBhvr>
-                                        <p:cTn id="13" dur="1000" fill="hold"/>
-                                        <p:tgtEl>
-                                          <p:spTgt spid="5"/>
-                                        </p:tgtEl>
-                                        <p:attrNameLst>
-                                          <p:attrName>ppt_x</p:attrName>
-                                        </p:attrNameLst>
-                                      </p:cBhvr>
-                                      <p:tavLst>
-                                        <p:tav tm="0">
-                                          <p:val>
-                                            <p:strVal val="#ppt_x"/>
-                                          </p:val>
-                                        </p:tav>
-                                        <p:tav tm="100000">
-                                          <p:val>
-                                            <p:strVal val="#ppt_x"/>
-                                          </p:val>
-                                        </p:tav>
-                                      </p:tavLst>
-                                    </p:anim>
-                                    <p:anim calcmode="lin" valueType="num">
-                                      <p:cBhvr>
-                                        <p:cTn id="14" dur="1000" fill="hold"/>
-                                        <p:tgtEl>
-                                          <p:spTgt spid="5"/>
-                                        </p:tgtEl>
-                                        <p:attrNameLst>
-                                          <p:attrName>ppt_y</p:attrName>
-                                        </p:attrNameLst>
-                                      </p:cBhvr>
-                                      <p:tavLst>
-                                        <p:tav tm="0">
-                                          <p:val>
-                                            <p:strVal val="#ppt_y+.1"/>
-                                          </p:val>
-                                        </p:tav>
-                                        <p:tav tm="100000">
-                                          <p:val>
-                                            <p:strVal val="#ppt_y"/>
-                                          </p:val>
-                                        </p:tav>
-                                      </p:tavLst>
-                                    </p:anim>
-                                  </p:childTnLst>
-                                </p:cTn>
-                              </p:par>
-                            </p:childTnLst>
-                          </p:cTn>
-                        </p:par>
-                      </p:childTnLst>
-                    </p:cTn>
-                  </p:par>
-                  <p:par>
-                    <p:cTn id="15" fill="hold">
-                      <p:stCondLst>
-                        <p:cond delay="indefinite"/>
-                      </p:stCondLst>
-                      <p:childTnLst>
-                        <p:par>
-                          <p:cTn id="16" fill="hold">
-                            <p:stCondLst>
-                              <p:cond delay="0"/>
-                            </p:stCondLst>
-                            <p:childTnLst>
-                              <p:par>
-                                <p:cTn id="17" presetID="42" presetClass="entr" presetSubtype="0" fill="hold" nodeType="clickEffect">
-                                  <p:stCondLst>
-                                    <p:cond delay="0"/>
-                                  </p:stCondLst>
-                                  <p:childTnLst>
-                                    <p:set>
-                                      <p:cBhvr>
-                                        <p:cTn id="18" dur="1" fill="hold">
-                                          <p:stCondLst>
-                                            <p:cond delay="0"/>
-                                          </p:stCondLst>
-                                        </p:cTn>
-                                        <p:tgtEl>
-                                          <p:spTgt spid="10"/>
-                                        </p:tgtEl>
-                                        <p:attrNameLst>
-                                          <p:attrName>style.visibility</p:attrName>
-                                        </p:attrNameLst>
-                                      </p:cBhvr>
-                                      <p:to>
-                                        <p:strVal val="visible"/>
-                                      </p:to>
-                                    </p:set>
-                                    <p:animEffect transition="in" filter="fade">
-                                      <p:cBhvr>
-                                        <p:cTn id="19" dur="1000"/>
-                                        <p:tgtEl>
-                                          <p:spTgt spid="10"/>
-                                        </p:tgtEl>
-                                      </p:cBhvr>
-                                    </p:animEffect>
-                                    <p:anim calcmode="lin" valueType="num">
-                                      <p:cBhvr>
-                                        <p:cTn id="20" dur="1000" fill="hold"/>
-                                        <p:tgtEl>
-                                          <p:spTgt spid="10"/>
-                                        </p:tgtEl>
-                                        <p:attrNameLst>
-                                          <p:attrName>ppt_x</p:attrName>
-                                        </p:attrNameLst>
-                                      </p:cBhvr>
-                                      <p:tavLst>
-                                        <p:tav tm="0">
-                                          <p:val>
-                                            <p:strVal val="#ppt_x"/>
-                                          </p:val>
-                                        </p:tav>
-                                        <p:tav tm="100000">
-                                          <p:val>
-                                            <p:strVal val="#ppt_x"/>
-                                          </p:val>
-                                        </p:tav>
-                                      </p:tavLst>
-                                    </p:anim>
-                                    <p:anim calcmode="lin" valueType="num">
-                                      <p:cBhvr>
-                                        <p:cTn id="21" dur="1000" fill="hold"/>
-                                        <p:tgtEl>
-                                          <p:spTgt spid="10"/>
-                                        </p:tgtEl>
-                                        <p:attrNameLst>
-                                          <p:attrName>ppt_y</p:attrName>
-                                        </p:attrNameLst>
-                                      </p:cBhvr>
-                                      <p:tavLst>
-                                        <p:tav tm="0">
-                                          <p:val>
-                                            <p:strVal val="#ppt_y+.1"/>
-                                          </p:val>
-                                        </p:tav>
-                                        <p:tav tm="100000">
-                                          <p:val>
-                                            <p:strVal val="#ppt_y"/>
-                                          </p:val>
-                                        </p:tav>
-                                      </p:tavLst>
-                                    </p:anim>
-                                  </p:childTnLst>
-                                </p:cTn>
-                              </p:par>
-                              <p:par>
-                                <p:cTn id="22" presetID="42" presetClass="entr" presetSubtype="0" fill="hold" grpId="0" nodeType="withEffect">
-                                  <p:stCondLst>
-                                    <p:cond delay="0"/>
-                                  </p:stCondLst>
-                                  <p:childTnLst>
-                                    <p:set>
-                                      <p:cBhvr>
-                                        <p:cTn id="23" dur="1" fill="hold">
-                                          <p:stCondLst>
-                                            <p:cond delay="0"/>
-                                          </p:stCondLst>
-                                        </p:cTn>
-                                        <p:tgtEl>
-                                          <p:spTgt spid="11"/>
-                                        </p:tgtEl>
-                                        <p:attrNameLst>
-                                          <p:attrName>style.visibility</p:attrName>
-                                        </p:attrNameLst>
-                                      </p:cBhvr>
-                                      <p:to>
-                                        <p:strVal val="visible"/>
-                                      </p:to>
-                                    </p:set>
-                                    <p:animEffect transition="in" filter="fade">
-                                      <p:cBhvr>
-                                        <p:cTn id="24" dur="1000"/>
-                                        <p:tgtEl>
-                                          <p:spTgt spid="11"/>
-                                        </p:tgtEl>
-                                      </p:cBhvr>
-                                    </p:animEffect>
-                                    <p:anim calcmode="lin" valueType="num">
-                                      <p:cBhvr>
-                                        <p:cTn id="25" dur="1000" fill="hold"/>
-                                        <p:tgtEl>
-                                          <p:spTgt spid="11"/>
-                                        </p:tgtEl>
-                                        <p:attrNameLst>
-                                          <p:attrName>ppt_x</p:attrName>
-                                        </p:attrNameLst>
-                                      </p:cBhvr>
-                                      <p:tavLst>
-                                        <p:tav tm="0">
-                                          <p:val>
-                                            <p:strVal val="#ppt_x"/>
-                                          </p:val>
-                                        </p:tav>
-                                        <p:tav tm="100000">
-                                          <p:val>
-                                            <p:strVal val="#ppt_x"/>
-                                          </p:val>
-                                        </p:tav>
-                                      </p:tavLst>
-                                    </p:anim>
-                                    <p:anim calcmode="lin" valueType="num">
-                                      <p:cBhvr>
-                                        <p:cTn id="26" dur="1000" fill="hold"/>
-                                        <p:tgtEl>
-                                          <p:spTgt spid="11"/>
-                                        </p:tgtEl>
-                                        <p:attrNameLst>
-                                          <p:attrName>ppt_y</p:attrName>
-                                        </p:attrNameLst>
-                                      </p:cBhvr>
-                                      <p:tavLst>
-                                        <p:tav tm="0">
-                                          <p:val>
-                                            <p:strVal val="#ppt_y+.1"/>
-                                          </p:val>
-                                        </p:tav>
-                                        <p:tav tm="100000">
-                                          <p:val>
-                                            <p:strVal val="#ppt_y"/>
-                                          </p:val>
-                                        </p:tav>
-                                      </p:tavLst>
-                                    </p:anim>
-                                  </p:childTnLst>
-                                </p:cTn>
-                              </p:par>
-                              <p:par>
-                                <p:cTn id="27" presetID="42" presetClass="entr" presetSubtype="0" fill="hold" grpId="0" nodeType="withEffect">
-                                  <p:stCondLst>
-                                    <p:cond delay="0"/>
-                                  </p:stCondLst>
-                                  <p:childTnLst>
-                                    <p:set>
-                                      <p:cBhvr>
-                                        <p:cTn id="28" dur="1" fill="hold">
-                                          <p:stCondLst>
-                                            <p:cond delay="0"/>
-                                          </p:stCondLst>
-                                        </p:cTn>
-                                        <p:tgtEl>
-                                          <p:spTgt spid="12"/>
-                                        </p:tgtEl>
-                                        <p:attrNameLst>
-                                          <p:attrName>style.visibility</p:attrName>
-                                        </p:attrNameLst>
-                                      </p:cBhvr>
-                                      <p:to>
-                                        <p:strVal val="visible"/>
-                                      </p:to>
-                                    </p:set>
-                                    <p:animEffect transition="in" filter="fade">
-                                      <p:cBhvr>
-                                        <p:cTn id="29" dur="1000"/>
-                                        <p:tgtEl>
-                                          <p:spTgt spid="12"/>
-                                        </p:tgtEl>
-                                      </p:cBhvr>
-                                    </p:animEffect>
-                                    <p:anim calcmode="lin" valueType="num">
-                                      <p:cBhvr>
-                                        <p:cTn id="30" dur="1000" fill="hold"/>
-                                        <p:tgtEl>
-                                          <p:spTgt spid="12"/>
-                                        </p:tgtEl>
-                                        <p:attrNameLst>
-                                          <p:attrName>ppt_x</p:attrName>
-                                        </p:attrNameLst>
-                                      </p:cBhvr>
-                                      <p:tavLst>
-                                        <p:tav tm="0">
-                                          <p:val>
-                                            <p:strVal val="#ppt_x"/>
-                                          </p:val>
-                                        </p:tav>
-                                        <p:tav tm="100000">
-                                          <p:val>
-                                            <p:strVal val="#ppt_x"/>
-                                          </p:val>
-                                        </p:tav>
-                                      </p:tavLst>
-                                    </p:anim>
-                                    <p:anim calcmode="lin" valueType="num">
-                                      <p:cBhvr>
-                                        <p:cTn id="31" dur="1000" fill="hold"/>
-                                        <p:tgtEl>
-                                          <p:spTgt spid="12"/>
-                                        </p:tgtEl>
-                                        <p:attrNameLst>
-                                          <p:attrName>ppt_y</p:attrName>
-                                        </p:attrNameLst>
-                                      </p:cBhvr>
-                                      <p:tavLst>
-                                        <p:tav tm="0">
-                                          <p:val>
-                                            <p:strVal val="#ppt_y+.1"/>
-                                          </p:val>
-                                        </p:tav>
-                                        <p:tav tm="100000">
-                                          <p:val>
-                                            <p:strVal val="#ppt_y"/>
-                                          </p:val>
-                                        </p:tav>
-                                      </p:tavLst>
-                                    </p:anim>
-                                  </p:childTnLst>
-                                </p:cTn>
-                              </p:par>
-                              <p:par>
-                                <p:cTn id="32" presetID="42" presetClass="entr" presetSubtype="0" fill="hold" grpId="0" nodeType="withEffect">
-                                  <p:stCondLst>
-                                    <p:cond delay="0"/>
-                                  </p:stCondLst>
-                                  <p:childTnLst>
-                                    <p:set>
-                                      <p:cBhvr>
-                                        <p:cTn id="33" dur="1" fill="hold">
-                                          <p:stCondLst>
-                                            <p:cond delay="0"/>
-                                          </p:stCondLst>
-                                        </p:cTn>
-                                        <p:tgtEl>
-                                          <p:spTgt spid="13"/>
-                                        </p:tgtEl>
-                                        <p:attrNameLst>
-                                          <p:attrName>style.visibility</p:attrName>
-                                        </p:attrNameLst>
-                                      </p:cBhvr>
-                                      <p:to>
-                                        <p:strVal val="visible"/>
-                                      </p:to>
-                                    </p:set>
-                                    <p:animEffect transition="in" filter="fade">
-                                      <p:cBhvr>
-                                        <p:cTn id="34" dur="1000"/>
-                                        <p:tgtEl>
-                                          <p:spTgt spid="13"/>
-                                        </p:tgtEl>
-                                      </p:cBhvr>
-                                    </p:animEffect>
-                                    <p:anim calcmode="lin" valueType="num">
-                                      <p:cBhvr>
-                                        <p:cTn id="35" dur="1000" fill="hold"/>
-                                        <p:tgtEl>
-                                          <p:spTgt spid="13"/>
-                                        </p:tgtEl>
-                                        <p:attrNameLst>
-                                          <p:attrName>ppt_x</p:attrName>
-                                        </p:attrNameLst>
-                                      </p:cBhvr>
-                                      <p:tavLst>
-                                        <p:tav tm="0">
-                                          <p:val>
-                                            <p:strVal val="#ppt_x"/>
-                                          </p:val>
-                                        </p:tav>
-                                        <p:tav tm="100000">
-                                          <p:val>
-                                            <p:strVal val="#ppt_x"/>
-                                          </p:val>
-                                        </p:tav>
-                                      </p:tavLst>
-                                    </p:anim>
-                                    <p:anim calcmode="lin" valueType="num">
-                                      <p:cBhvr>
-                                        <p:cTn id="36" dur="1000" fill="hold"/>
-                                        <p:tgtEl>
-                                          <p:spTgt spid="13"/>
-                                        </p:tgtEl>
-                                        <p:attrNameLst>
-                                          <p:attrName>ppt_y</p:attrName>
-                                        </p:attrNameLst>
-                                      </p:cBhvr>
-                                      <p:tavLst>
-                                        <p:tav tm="0">
-                                          <p:val>
-                                            <p:strVal val="#ppt_y+.1"/>
-                                          </p:val>
-                                        </p:tav>
-                                        <p:tav tm="100000">
-                                          <p:val>
-                                            <p:strVal val="#ppt_y"/>
-                                          </p:val>
-                                        </p:tav>
-                                      </p:tavLst>
-                                    </p:anim>
-                                  </p:childTnLst>
-                                </p:cTn>
-                              </p:par>
-                            </p:childTnLst>
-                          </p:cTn>
-                        </p:par>
-                      </p:childTnLst>
-                    </p:cTn>
-                  </p:par>
-                  <p:par>
-                    <p:cTn id="37" fill="hold">
-                      <p:stCondLst>
-                        <p:cond delay="indefinite"/>
-                      </p:stCondLst>
-                      <p:childTnLst>
-                        <p:par>
-                          <p:cTn id="38" fill="hold">
-                            <p:stCondLst>
-                              <p:cond delay="0"/>
-                            </p:stCondLst>
-                            <p:childTnLst>
-                              <p:par>
-                                <p:cTn id="39" presetID="42" presetClass="entr" presetSubtype="0" fill="hold" nodeType="clickEffect">
-                                  <p:stCondLst>
-                                    <p:cond delay="0"/>
-                                  </p:stCondLst>
-                                  <p:childTnLst>
-                                    <p:set>
-                                      <p:cBhvr>
-                                        <p:cTn id="40" dur="1" fill="hold">
-                                          <p:stCondLst>
-                                            <p:cond delay="0"/>
-                                          </p:stCondLst>
-                                        </p:cTn>
-                                        <p:tgtEl>
-                                          <p:spTgt spid="17"/>
-                                        </p:tgtEl>
-                                        <p:attrNameLst>
-                                          <p:attrName>style.visibility</p:attrName>
-                                        </p:attrNameLst>
-                                      </p:cBhvr>
-                                      <p:to>
-                                        <p:strVal val="visible"/>
-                                      </p:to>
-                                    </p:set>
-                                    <p:animEffect transition="in" filter="fade">
-                                      <p:cBhvr>
-                                        <p:cTn id="41" dur="1000"/>
-                                        <p:tgtEl>
-                                          <p:spTgt spid="17"/>
-                                        </p:tgtEl>
-                                      </p:cBhvr>
-                                    </p:animEffect>
-                                    <p:anim calcmode="lin" valueType="num">
-                                      <p:cBhvr>
-                                        <p:cTn id="42" dur="1000" fill="hold"/>
-                                        <p:tgtEl>
-                                          <p:spTgt spid="17"/>
-                                        </p:tgtEl>
-                                        <p:attrNameLst>
-                                          <p:attrName>ppt_x</p:attrName>
-                                        </p:attrNameLst>
-                                      </p:cBhvr>
-                                      <p:tavLst>
-                                        <p:tav tm="0">
-                                          <p:val>
-                                            <p:strVal val="#ppt_x"/>
-                                          </p:val>
-                                        </p:tav>
-                                        <p:tav tm="100000">
-                                          <p:val>
-                                            <p:strVal val="#ppt_x"/>
-                                          </p:val>
-                                        </p:tav>
-                                      </p:tavLst>
-                                    </p:anim>
-                                    <p:anim calcmode="lin" valueType="num">
-                                      <p:cBhvr>
-                                        <p:cTn id="43" dur="1000" fill="hold"/>
-                                        <p:tgtEl>
-                                          <p:spTgt spid="17"/>
-                                        </p:tgtEl>
-                                        <p:attrNameLst>
-                                          <p:attrName>ppt_y</p:attrName>
-                                        </p:attrNameLst>
-                                      </p:cBhvr>
-                                      <p:tavLst>
-                                        <p:tav tm="0">
-                                          <p:val>
-                                            <p:strVal val="#ppt_y+.1"/>
-                                          </p:val>
-                                        </p:tav>
-                                        <p:tav tm="100000">
-                                          <p:val>
-                                            <p:strVal val="#ppt_y"/>
-                                          </p:val>
-                                        </p:tav>
-                                      </p:tavLst>
-                                    </p:anim>
-                                  </p:childTnLst>
-                                </p:cTn>
-                              </p:par>
-                              <p:par>
-                                <p:cTn id="44" presetID="42" presetClass="entr" presetSubtype="0" fill="hold" grpId="0" nodeType="withEffect">
-                                  <p:stCondLst>
-                                    <p:cond delay="0"/>
-                                  </p:stCondLst>
-                                  <p:childTnLst>
-                                    <p:set>
-                                      <p:cBhvr>
-                                        <p:cTn id="45" dur="1" fill="hold">
-                                          <p:stCondLst>
-                                            <p:cond delay="0"/>
-                                          </p:stCondLst>
-                                        </p:cTn>
-                                        <p:tgtEl>
-                                          <p:spTgt spid="7"/>
-                                        </p:tgtEl>
-                                        <p:attrNameLst>
-                                          <p:attrName>style.visibility</p:attrName>
-                                        </p:attrNameLst>
-                                      </p:cBhvr>
-                                      <p:to>
-                                        <p:strVal val="visible"/>
-                                      </p:to>
-                                    </p:set>
-                                    <p:animEffect transition="in" filter="fade">
-                                      <p:cBhvr>
-                                        <p:cTn id="46" dur="1000"/>
-                                        <p:tgtEl>
-                                          <p:spTgt spid="7"/>
-                                        </p:tgtEl>
-                                      </p:cBhvr>
-                                    </p:animEffect>
-                                    <p:anim calcmode="lin" valueType="num">
-                                      <p:cBhvr>
-                                        <p:cTn id="47" dur="1000" fill="hold"/>
-                                        <p:tgtEl>
-                                          <p:spTgt spid="7"/>
-                                        </p:tgtEl>
-                                        <p:attrNameLst>
-                                          <p:attrName>ppt_x</p:attrName>
-                                        </p:attrNameLst>
-                                      </p:cBhvr>
-                                      <p:tavLst>
-                                        <p:tav tm="0">
-                                          <p:val>
-                                            <p:strVal val="#ppt_x"/>
-                                          </p:val>
-                                        </p:tav>
-                                        <p:tav tm="100000">
-                                          <p:val>
-                                            <p:strVal val="#ppt_x"/>
-                                          </p:val>
-                                        </p:tav>
-                                      </p:tavLst>
-                                    </p:anim>
-                                    <p:anim calcmode="lin" valueType="num">
-                                      <p:cBhvr>
-                                        <p:cTn id="48" dur="1000" fill="hold"/>
-                                        <p:tgtEl>
-                                          <p:spTgt spid="7"/>
-                                        </p:tgtEl>
-                                        <p:attrNameLst>
-                                          <p:attrName>ppt_y</p:attrName>
-                                        </p:attrNameLst>
-                                      </p:cBhvr>
-                                      <p:tavLst>
-                                        <p:tav tm="0">
-                                          <p:val>
-                                            <p:strVal val="#ppt_y+.1"/>
-                                          </p:val>
-                                        </p:tav>
-                                        <p:tav tm="100000">
-                                          <p:val>
-                                            <p:strVal val="#ppt_y"/>
-                                          </p:val>
-                                        </p:tav>
-                                      </p:tavLst>
-                                    </p:anim>
-                                  </p:childTnLst>
-                                </p:cTn>
-                              </p:par>
-                            </p:childTnLst>
-                          </p:cTn>
-                        </p:par>
-                      </p:childTnLst>
-                    </p:cTn>
-                  </p:par>
-                  <p:par>
-                    <p:cTn id="49" fill="hold">
-                      <p:stCondLst>
-                        <p:cond delay="indefinite"/>
-                      </p:stCondLst>
-                      <p:childTnLst>
-                        <p:par>
-                          <p:cTn id="50" fill="hold">
-                            <p:stCondLst>
-                              <p:cond delay="0"/>
-                            </p:stCondLst>
-                            <p:childTnLst>
-                              <p:par>
-                                <p:cTn id="51" presetID="42" presetClass="entr" presetSubtype="0" fill="hold" nodeType="clickEffect">
-                                  <p:stCondLst>
-                                    <p:cond delay="0"/>
-                                  </p:stCondLst>
-                                  <p:childTnLst>
-                                    <p:set>
-                                      <p:cBhvr>
-                                        <p:cTn id="52" dur="1" fill="hold">
-                                          <p:stCondLst>
-                                            <p:cond delay="0"/>
-                                          </p:stCondLst>
-                                        </p:cTn>
-                                        <p:tgtEl>
-                                          <p:spTgt spid="19"/>
-                                        </p:tgtEl>
-                                        <p:attrNameLst>
-                                          <p:attrName>style.visibility</p:attrName>
-                                        </p:attrNameLst>
-                                      </p:cBhvr>
-                                      <p:to>
-                                        <p:strVal val="visible"/>
-                                      </p:to>
-                                    </p:set>
-                                    <p:animEffect transition="in" filter="fade">
-                                      <p:cBhvr>
-                                        <p:cTn id="53" dur="1000"/>
-                                        <p:tgtEl>
-                                          <p:spTgt spid="19"/>
-                                        </p:tgtEl>
-                                      </p:cBhvr>
-                                    </p:animEffect>
-                                    <p:anim calcmode="lin" valueType="num">
-                                      <p:cBhvr>
-                                        <p:cTn id="54" dur="1000" fill="hold"/>
-                                        <p:tgtEl>
-                                          <p:spTgt spid="19"/>
-                                        </p:tgtEl>
-                                        <p:attrNameLst>
-                                          <p:attrName>ppt_x</p:attrName>
-                                        </p:attrNameLst>
-                                      </p:cBhvr>
-                                      <p:tavLst>
-                                        <p:tav tm="0">
-                                          <p:val>
-                                            <p:strVal val="#ppt_x"/>
-                                          </p:val>
-                                        </p:tav>
-                                        <p:tav tm="100000">
-                                          <p:val>
-                                            <p:strVal val="#ppt_x"/>
-                                          </p:val>
-                                        </p:tav>
-                                      </p:tavLst>
-                                    </p:anim>
-                                    <p:anim calcmode="lin" valueType="num">
-                                      <p:cBhvr>
-                                        <p:cTn id="55" dur="1000" fill="hold"/>
-                                        <p:tgtEl>
-                                          <p:spTgt spid="19"/>
-                                        </p:tgtEl>
-                                        <p:attrNameLst>
-                                          <p:attrName>ppt_y</p:attrName>
-                                        </p:attrNameLst>
-                                      </p:cBhvr>
-                                      <p:tavLst>
-                                        <p:tav tm="0">
-                                          <p:val>
-                                            <p:strVal val="#ppt_y+.1"/>
-                                          </p:val>
-                                        </p:tav>
-                                        <p:tav tm="100000">
-                                          <p:val>
-                                            <p:strVal val="#ppt_y"/>
-                                          </p:val>
-                                        </p:tav>
-                                      </p:tavLst>
-                                    </p:anim>
-                                  </p:childTnLst>
-                                </p:cTn>
-                              </p:par>
-                              <p:par>
-                                <p:cTn id="56" presetID="42" presetClass="entr" presetSubtype="0" fill="hold" nodeType="withEffect">
-                                  <p:stCondLst>
-                                    <p:cond delay="0"/>
-                                  </p:stCondLst>
-                                  <p:childTnLst>
-                                    <p:set>
-                                      <p:cBhvr>
-                                        <p:cTn id="57" dur="1" fill="hold">
-                                          <p:stCondLst>
-                                            <p:cond delay="0"/>
-                                          </p:stCondLst>
-                                        </p:cTn>
-                                        <p:tgtEl>
-                                          <p:spTgt spid="21"/>
-                                        </p:tgtEl>
-                                        <p:attrNameLst>
-                                          <p:attrName>style.visibility</p:attrName>
-                                        </p:attrNameLst>
-                                      </p:cBhvr>
-                                      <p:to>
-                                        <p:strVal val="visible"/>
-                                      </p:to>
-                                    </p:set>
-                                    <p:animEffect transition="in" filter="fade">
-                                      <p:cBhvr>
-                                        <p:cTn id="58" dur="1000"/>
-                                        <p:tgtEl>
-                                          <p:spTgt spid="21"/>
-                                        </p:tgtEl>
-                                      </p:cBhvr>
-                                    </p:animEffect>
-                                    <p:anim calcmode="lin" valueType="num">
-                                      <p:cBhvr>
-                                        <p:cTn id="59" dur="1000" fill="hold"/>
-                                        <p:tgtEl>
-                                          <p:spTgt spid="21"/>
-                                        </p:tgtEl>
-                                        <p:attrNameLst>
-                                          <p:attrName>ppt_x</p:attrName>
-                                        </p:attrNameLst>
-                                      </p:cBhvr>
-                                      <p:tavLst>
-                                        <p:tav tm="0">
-                                          <p:val>
-                                            <p:strVal val="#ppt_x"/>
-                                          </p:val>
-                                        </p:tav>
-                                        <p:tav tm="100000">
-                                          <p:val>
-                                            <p:strVal val="#ppt_x"/>
-                                          </p:val>
-                                        </p:tav>
-                                      </p:tavLst>
-                                    </p:anim>
-                                    <p:anim calcmode="lin" valueType="num">
-                                      <p:cBhvr>
-                                        <p:cTn id="60" dur="1000" fill="hold"/>
-                                        <p:tgtEl>
-                                          <p:spTgt spid="21"/>
-                                        </p:tgtEl>
-                                        <p:attrNameLst>
-                                          <p:attrName>ppt_y</p:attrName>
-                                        </p:attrNameLst>
-                                      </p:cBhvr>
-                                      <p:tavLst>
-                                        <p:tav tm="0">
-                                          <p:val>
-                                            <p:strVal val="#ppt_y+.1"/>
-                                          </p:val>
-                                        </p:tav>
-                                        <p:tav tm="100000">
-                                          <p:val>
-                                            <p:strVal val="#ppt_y"/>
-                                          </p:val>
-                                        </p:tav>
-                                      </p:tavLst>
-                                    </p:anim>
-                                  </p:childTnLst>
-                                </p:cTn>
-                              </p:par>
-                              <p:par>
-                                <p:cTn id="61" presetID="42" presetClass="entr" presetSubtype="0" fill="hold" grpId="0" nodeType="withEffect">
-                                  <p:stCondLst>
-                                    <p:cond delay="0"/>
-                                  </p:stCondLst>
-                                  <p:childTnLst>
-                                    <p:set>
-                                      <p:cBhvr>
-                                        <p:cTn id="62" dur="1" fill="hold">
-                                          <p:stCondLst>
-                                            <p:cond delay="0"/>
-                                          </p:stCondLst>
-                                        </p:cTn>
-                                        <p:tgtEl>
-                                          <p:spTgt spid="9"/>
-                                        </p:tgtEl>
-                                        <p:attrNameLst>
-                                          <p:attrName>style.visibility</p:attrName>
-                                        </p:attrNameLst>
-                                      </p:cBhvr>
-                                      <p:to>
-                                        <p:strVal val="visible"/>
-                                      </p:to>
-                                    </p:set>
-                                    <p:animEffect transition="in" filter="fade">
-                                      <p:cBhvr>
-                                        <p:cTn id="63" dur="1000"/>
-                                        <p:tgtEl>
-                                          <p:spTgt spid="9"/>
-                                        </p:tgtEl>
-                                      </p:cBhvr>
-                                    </p:animEffect>
-                                    <p:anim calcmode="lin" valueType="num">
-                                      <p:cBhvr>
-                                        <p:cTn id="64" dur="1000" fill="hold"/>
-                                        <p:tgtEl>
-                                          <p:spTgt spid="9"/>
-                                        </p:tgtEl>
-                                        <p:attrNameLst>
-                                          <p:attrName>ppt_x</p:attrName>
-                                        </p:attrNameLst>
-                                      </p:cBhvr>
-                                      <p:tavLst>
-                                        <p:tav tm="0">
-                                          <p:val>
-                                            <p:strVal val="#ppt_x"/>
-                                          </p:val>
-                                        </p:tav>
-                                        <p:tav tm="100000">
-                                          <p:val>
-                                            <p:strVal val="#ppt_x"/>
-                                          </p:val>
-                                        </p:tav>
-                                      </p:tavLst>
-                                    </p:anim>
-                                    <p:anim calcmode="lin" valueType="num">
-                                      <p:cBhvr>
-                                        <p:cTn id="65" dur="1000" fill="hold"/>
-                                        <p:tgtEl>
-                                          <p:spTgt spid="9"/>
-                                        </p:tgtEl>
-                                        <p:attrNameLst>
-                                          <p:attrName>ppt_y</p:attrName>
-                                        </p:attrNameLst>
-                                      </p:cBhvr>
-                                      <p:tavLst>
-                                        <p:tav tm="0">
-                                          <p:val>
-                                            <p:strVal val="#ppt_y+.1"/>
-                                          </p:val>
-                                        </p:tav>
-                                        <p:tav tm="100000">
-                                          <p:val>
-                                            <p:strVal val="#ppt_y"/>
-                                          </p:val>
-                                        </p:tav>
-                                      </p:tavLst>
-                                    </p:anim>
-                                  </p:childTnLst>
-                                </p:cTn>
-                              </p:par>
-                            </p:childTnLst>
-                          </p:cTn>
-                        </p:par>
-                      </p:childTnLst>
-                    </p:cTn>
-                  </p:par>
-                </p:childTnLst>
-              </p:cTn>
-              <p:prevCondLst>
-                <p:cond evt="onPrev" delay="0">
-                  <p:tgtEl>
-                    <p:sldTgt/>
-                  </p:tgtEl>
-                </p:cond>
-              </p:prevCondLst>
-              <p:nextCondLst>
-                <p:cond evt="onNext" delay="0">
-                  <p:tgtEl>
-                    <p:sldTgt/>
-                  </p:tgtEl>
-                </p:cond>
-              </p:nextCondLst>
-            </p:seq>
-          </p:childTnLst>
-        </p:cTn>
-      </p:par>
-    </p:tnLst>
-    <p:bldLst>
-      <p:bldP spid="5" grpId="0" animBg="1"/>
-      <p:bldP spid="7" grpId="0" animBg="1"/>
-      <p:bldP spid="9" grpId="0" animBg="1"/>
-      <p:bldP spid="11" grpId="0" animBg="1"/>
-      <p:bldP spid="12" grpId="0" animBg="1"/>
-      <p:bldP spid="13" grpId="0" animBg="1"/>
-    </p:bldLst>
-  </p:timing>
 </p:sld>
 </file>
 

</xml_diff>